<commit_message>
Office export from plain photos: flatten, high-res reading, line rereads
- Photos of a page on a desk are flattened like a scan (page detection,
  perspective, paper cleanup) and snapped to Letter/A4 before rebuilding
- Text is recognized from a higher-resolution copy; every line and table
  cell is reread on its own and accepted only for plausible corrections
- Page-relative bold threshold, stricter bullet dots, list items no longer
  swallow the next item, "81" → "B1" in code columns, consistent ranges
- Raw photo fixture and test with rendered outputs

Co-Authored-By: Claude Opus 5.5 <noreply@anthropic.com>
Claude-Session: https://claude.ai/code/session_01N2KPqXq9Whv7eR2vrvkBWC
</commit_message>
<xml_diff>
--- a/ios/Verification/office-layout/OfficeSamplePriceList.pptx
+++ b/ios/Verification/office-layout/OfficeSamplePriceList.pptx
@@ -1812,7 +1812,7 @@
                 <a:ea typeface="Malgun Gothic"/>
                 <a:cs typeface="Arial"/>
               </a:rPr>
-              <a:t> trust'.</a:t>
+              <a:t> trust.</a:t>
             </a:r>
           </a:p>
         </p:txBody>
@@ -2014,7 +2014,7 @@
                 <a:ea typeface="Malgun Gothic"/>
                 <a:cs typeface="Arial"/>
               </a:rPr>
-              <a:t>CONCERT</a:t>
+              <a:t>CONCERT®</a:t>
             </a:r>
           </a:p>
         </p:txBody>

</xml_diff>